<commit_message>
Cybercast A4: dates read Tuesday 20 October 2026 and Wednesday 21 October 2026
Co-Authored-By: Claude Opus 5.5 <noreply@anthropic.com>
Claude-Session: https://claude.ai/code/session_011hZGnXfR5VyWzMmXYbY7jX
</commit_message>
<xml_diff>
--- a/women-on-course-guest-day/canva/woc-spin-the-wheel-A4-editable.pptx
+++ b/women-on-course-guest-day/canva/woc-spin-the-wheel-A4-editable.pptx
@@ -3621,13 +3621,13 @@
           <a:p>
             <a:pPr algn="ctr"/>
             <a:r>
-              <a:rPr sz="816" b="0" spc="192">
+              <a:rPr sz="1055" b="0">
                 <a:solidFill>
                   <a:srgbClr val="F9F6F1"/>
                 </a:solidFill>
                 <a:latin typeface="Montserrat"/>
               </a:rPr>
-              <a:t>TUESDAY 20 OCTOBER 2026  &amp;  WEDNESDAY 21 OCTOBER 2026</a:t>
+              <a:t>Tuesday 20 October 2026 and Wednesday 21 October 2026</a:t>
             </a:r>
           </a:p>
         </p:txBody>

</xml_diff>